<commit_message>
Add narrative PPTX + update light PPTX with split-panel cover
- Light PPTX: new split-panel cover (title left, navy panel with
  01/02/03 flow steps on right)
- Narrative PPTX: completely different design — horizontal bands
  (amber problem, teal solution chips, emerald impact metrics)
  with asymmetric split cover

https://claude.ai/code/session_01BAR2yXBQHbTRdP9CC9qS9i
</commit_message>
<xml_diff>
--- a/Demo One Slider - Light.pptx
+++ b/Demo One Slider - Light.pptx
@@ -3100,37 +3100,44 @@
       <p:grpSpPr/>
       <p:sp>
         <p:nvSpPr>
-          <p:cNvPr id="2" name="TextBox 1"/>
-          <p:cNvSpPr txBox="1"/>
-          <p:nvPr/>
-        </p:nvSpPr>
-        <p:spPr>
-          <a:xfrm>
-            <a:off x="731520" y="548640"/>
-            <a:ext cx="2743200" cy="365760"/>
-          </a:xfrm>
-          <a:prstGeom prst="rect">
-            <a:avLst/>
-          </a:prstGeom>
-          <a:noFill/>
-        </p:spPr>
-        <p:txBody>
-          <a:bodyPr wrap="square">
-            <a:spAutoFit/>
-          </a:bodyPr>
-          <a:lstStyle/>
-          <a:p>
-            <a:pPr algn="l">
-              <a:defRPr sz="1600" b="1" i="0">
-                <a:solidFill>
-                  <a:srgbClr val="7B8198"/>
-                </a:solidFill>
-                <a:latin typeface="Inter"/>
-              </a:defRPr>
-            </a:pPr>
-            <a:r>
-              <a:t>CAPCO</a:t>
-            </a:r>
+          <p:cNvPr id="2" name="Rectangle 1"/>
+          <p:cNvSpPr/>
+          <p:nvPr/>
+        </p:nvSpPr>
+        <p:spPr>
+          <a:xfrm>
+            <a:off x="7071183" y="0"/>
+            <a:ext cx="5120511" cy="6858000"/>
+          </a:xfrm>
+          <a:prstGeom prst="rect">
+            <a:avLst/>
+          </a:prstGeom>
+          <a:solidFill>
+            <a:srgbClr val="1A1F3D"/>
+          </a:solidFill>
+          <a:ln>
+            <a:noFill/>
+          </a:ln>
+        </p:spPr>
+        <p:style>
+          <a:lnRef idx="1">
+            <a:schemeClr val="accent1"/>
+          </a:lnRef>
+          <a:fillRef idx="3">
+            <a:schemeClr val="accent1"/>
+          </a:fillRef>
+          <a:effectRef idx="2">
+            <a:schemeClr val="accent1"/>
+          </a:effectRef>
+          <a:fontRef idx="minor">
+            <a:schemeClr val="lt1"/>
+          </a:fontRef>
+        </p:style>
+        <p:txBody>
+          <a:bodyPr rtlCol="0" anchor="ctr"/>
+          <a:lstStyle/>
+          <a:p>
+            <a:pPr algn="ctr"/>
           </a:p>
         </p:txBody>
       </p:sp>
@@ -3142,8 +3149,8 @@
         </p:nvSpPr>
         <p:spPr>
           <a:xfrm>
-            <a:off x="731520" y="2194560"/>
-            <a:ext cx="548640" cy="54864"/>
+            <a:off x="7071183" y="6803136"/>
+            <a:ext cx="5120511" cy="54864"/>
           </a:xfrm>
           <a:prstGeom prst="rect">
             <a:avLst/>
@@ -3185,8 +3192,8 @@
         </p:nvSpPr>
         <p:spPr>
           <a:xfrm>
-            <a:off x="731520" y="2423160"/>
-            <a:ext cx="8229600" cy="1463040"/>
+            <a:off x="731520" y="548640"/>
+            <a:ext cx="2743200" cy="365760"/>
           </a:xfrm>
           <a:prstGeom prst="rect">
             <a:avLst/>
@@ -3200,69 +3207,29 @@
           <a:lstStyle/>
           <a:p>
             <a:pPr algn="l">
-              <a:defRPr sz="4800" b="1" i="0">
-                <a:solidFill>
-                  <a:srgbClr val="1A1F3D"/>
-                </a:solidFill>
-                <a:latin typeface="Inter"/>
+              <a:defRPr sz="1400" b="1" i="0">
+                <a:solidFill>
+                  <a:srgbClr val="7B8198"/>
+                </a:solidFill>
+                <a:latin typeface="Arial"/>
               </a:defRPr>
             </a:pPr>
             <a:r>
-              <a:t>AI Demo</a:t>
-            </a:r>
-            <a:br/>
-            <a:r>
-              <a:t>One Slider</a:t>
-            </a:r>
-          </a:p>
-        </p:txBody>
-      </p:sp>
-      <p:sp>
-        <p:nvSpPr>
-          <p:cNvPr id="5" name="TextBox 4"/>
-          <p:cNvSpPr txBox="1"/>
-          <p:nvPr/>
-        </p:nvSpPr>
-        <p:spPr>
-          <a:xfrm>
-            <a:off x="731520" y="4114800"/>
-            <a:ext cx="7315200" cy="731520"/>
-          </a:xfrm>
-          <a:prstGeom prst="rect">
-            <a:avLst/>
-          </a:prstGeom>
-          <a:noFill/>
-        </p:spPr>
-        <p:txBody>
-          <a:bodyPr wrap="square">
-            <a:spAutoFit/>
-          </a:bodyPr>
-          <a:lstStyle/>
-          <a:p>
-            <a:pPr algn="l">
-              <a:defRPr sz="1600" b="0" i="0">
-                <a:solidFill>
-                  <a:srgbClr val="4A5068"/>
-                </a:solidFill>
-                <a:latin typeface="Inter"/>
-              </a:defRPr>
-            </a:pPr>
-            <a:r>
-              <a:t>Your executive primer before the live demo — the business problem, the AI solution, and the impact, all on a single slide.</a:t>
-            </a:r>
-          </a:p>
-        </p:txBody>
-      </p:sp>
-      <p:sp>
-        <p:nvSpPr>
-          <p:cNvPr id="6" name="Rectangle 5"/>
+              <a:t>CAPCO</a:t>
+            </a:r>
+          </a:p>
+        </p:txBody>
+      </p:sp>
+      <p:sp>
+        <p:nvSpPr>
+          <p:cNvPr id="5" name="Rectangle 4"/>
           <p:cNvSpPr/>
           <p:nvPr/>
         </p:nvSpPr>
         <p:spPr>
           <a:xfrm>
-            <a:off x="731520" y="5943600"/>
-            <a:ext cx="548640" cy="36576"/>
+            <a:off x="731520" y="2011680"/>
+            <a:ext cx="457200" cy="45720"/>
           </a:xfrm>
           <a:prstGeom prst="rect">
             <a:avLst/>
@@ -3298,14 +3265,14 @@
       </p:sp>
       <p:sp>
         <p:nvSpPr>
-          <p:cNvPr id="7" name="TextBox 6"/>
+          <p:cNvPr id="6" name="TextBox 5"/>
           <p:cNvSpPr txBox="1"/>
           <p:nvPr/>
         </p:nvSpPr>
         <p:spPr>
           <a:xfrm>
-            <a:off x="731520" y="6080760"/>
-            <a:ext cx="2743200" cy="274320"/>
+            <a:off x="731520" y="2286000"/>
+            <a:ext cx="5943600" cy="1645920"/>
           </a:xfrm>
           <a:prstGeom prst="rect">
             <a:avLst/>
@@ -3319,29 +3286,33 @@
           <a:lstStyle/>
           <a:p>
             <a:pPr algn="l">
-              <a:defRPr sz="1000" b="1" i="0">
-                <a:solidFill>
-                  <a:srgbClr val="7B8198"/>
-                </a:solidFill>
-                <a:latin typeface="Inter"/>
+              <a:defRPr sz="4800" b="1" i="0">
+                <a:solidFill>
+                  <a:srgbClr val="1A1F3D"/>
+                </a:solidFill>
+                <a:latin typeface="Arial"/>
               </a:defRPr>
             </a:pPr>
             <a:r>
-              <a:t>COVER FORMAT</a:t>
-            </a:r>
-          </a:p>
-        </p:txBody>
-      </p:sp>
-      <p:sp>
-        <p:nvSpPr>
-          <p:cNvPr id="8" name="TextBox 7"/>
+              <a:t>AI Demo</a:t>
+            </a:r>
+            <a:br/>
+            <a:r>
+              <a:t>One Slider</a:t>
+            </a:r>
+          </a:p>
+        </p:txBody>
+      </p:sp>
+      <p:sp>
+        <p:nvSpPr>
+          <p:cNvPr id="7" name="TextBox 6"/>
           <p:cNvSpPr txBox="1"/>
           <p:nvPr/>
         </p:nvSpPr>
         <p:spPr>
           <a:xfrm>
-            <a:off x="731520" y="6355080"/>
-            <a:ext cx="9144000" cy="365760"/>
+            <a:off x="731520" y="4114800"/>
+            <a:ext cx="5943600" cy="731520"/>
           </a:xfrm>
           <a:prstGeom prst="rect">
             <a:avLst/>
@@ -3354,24 +3325,495 @@
           </a:bodyPr>
           <a:lstStyle/>
           <a:p>
+            <a:pPr algn="l">
+              <a:defRPr sz="1500" b="0" i="0">
+                <a:solidFill>
+                  <a:srgbClr val="4A5068"/>
+                </a:solidFill>
+                <a:latin typeface="Arial"/>
+              </a:defRPr>
+            </a:pPr>
+            <a:r>
+              <a:t>Your executive primer before the live demo — the business problem, the AI solution, and the impact, all on a single slide.</a:t>
+            </a:r>
+          </a:p>
+        </p:txBody>
+      </p:sp>
+      <p:sp>
+        <p:nvSpPr>
+          <p:cNvPr id="8" name="Rectangle 7"/>
+          <p:cNvSpPr/>
+          <p:nvPr/>
+        </p:nvSpPr>
+        <p:spPr>
+          <a:xfrm>
+            <a:off x="640080" y="5577840"/>
+            <a:ext cx="5669280" cy="548640"/>
+          </a:xfrm>
+          <a:prstGeom prst="rect">
+            <a:avLst/>
+          </a:prstGeom>
+          <a:solidFill>
+            <a:srgbClr val="FFFFFF"/>
+          </a:solidFill>
+          <a:ln w="12700">
+            <a:solidFill>
+              <a:srgbClr val="D4DAE5"/>
+            </a:solidFill>
+          </a:ln>
+        </p:spPr>
+        <p:style>
+          <a:lnRef idx="1">
+            <a:schemeClr val="accent1"/>
+          </a:lnRef>
+          <a:fillRef idx="3">
+            <a:schemeClr val="accent1"/>
+          </a:fillRef>
+          <a:effectRef idx="2">
+            <a:schemeClr val="accent1"/>
+          </a:effectRef>
+          <a:fontRef idx="minor">
+            <a:schemeClr val="lt1"/>
+          </a:fontRef>
+        </p:style>
+        <p:txBody>
+          <a:bodyPr rtlCol="0" anchor="ctr"/>
+          <a:lstStyle/>
+          <a:p>
+            <a:pPr algn="ctr"/>
+          </a:p>
+        </p:txBody>
+      </p:sp>
+      <p:sp>
+        <p:nvSpPr>
+          <p:cNvPr id="9" name="TextBox 8"/>
+          <p:cNvSpPr txBox="1"/>
+          <p:nvPr/>
+        </p:nvSpPr>
+        <p:spPr>
+          <a:xfrm>
+            <a:off x="822960" y="5669280"/>
+            <a:ext cx="5303520" cy="365760"/>
+          </a:xfrm>
+          <a:prstGeom prst="rect">
+            <a:avLst/>
+          </a:prstGeom>
+          <a:noFill/>
+        </p:spPr>
+        <p:txBody>
+          <a:bodyPr wrap="square">
+            <a:spAutoFit/>
+          </a:bodyPr>
+          <a:lstStyle/>
+          <a:p>
             <a:pPr algn="l"/>
             <a:r>
-              <a:rPr sz="1400" b="1" i="0">
+              <a:rPr sz="1000" b="0" i="0">
+                <a:solidFill>
+                  <a:srgbClr val="E6007E"/>
+                </a:solidFill>
+                <a:latin typeface="Arial"/>
+              </a:rPr>
+              <a:t>▶ </a:t>
+            </a:r>
+            <a:r>
+              <a:rPr sz="1200" b="1" i="0">
                 <a:solidFill>
                   <a:srgbClr val="1A1F3D"/>
                 </a:solidFill>
-                <a:latin typeface="Inter"/>
+                <a:latin typeface="Arial"/>
               </a:rPr>
               <a:t>[Solution Name]</a:t>
             </a:r>
             <a:r>
-              <a:rPr sz="1400" b="0" i="0">
+              <a:rPr sz="1200" b="0" i="0">
                 <a:solidFill>
                   <a:srgbClr val="7B8198"/>
                 </a:solidFill>
-                <a:latin typeface="Inter"/>
+                <a:latin typeface="Arial"/>
               </a:rPr>
-              <a:t>  —  One-line description of what it does and why it matters</a:t>
+              <a:t> — Short description</a:t>
+            </a:r>
+          </a:p>
+        </p:txBody>
+      </p:sp>
+      <p:sp>
+        <p:nvSpPr>
+          <p:cNvPr id="10" name="TextBox 9"/>
+          <p:cNvSpPr txBox="1"/>
+          <p:nvPr/>
+        </p:nvSpPr>
+        <p:spPr>
+          <a:xfrm>
+            <a:off x="7619823" y="914400"/>
+            <a:ext cx="3657600" cy="274320"/>
+          </a:xfrm>
+          <a:prstGeom prst="rect">
+            <a:avLst/>
+          </a:prstGeom>
+          <a:noFill/>
+        </p:spPr>
+        <p:txBody>
+          <a:bodyPr wrap="square">
+            <a:spAutoFit/>
+          </a:bodyPr>
+          <a:lstStyle/>
+          <a:p>
+            <a:pPr algn="l">
+              <a:defRPr sz="900" b="1" i="0">
+                <a:solidFill>
+                  <a:srgbClr val="555A78"/>
+                </a:solidFill>
+                <a:latin typeface="Arial"/>
+              </a:defRPr>
+            </a:pPr>
+            <a:r>
+              <a:t>SLIDE STRUCTURE</a:t>
+            </a:r>
+          </a:p>
+        </p:txBody>
+      </p:sp>
+      <p:sp>
+        <p:nvSpPr>
+          <p:cNvPr id="11" name="TextBox 10"/>
+          <p:cNvSpPr txBox="1"/>
+          <p:nvPr/>
+        </p:nvSpPr>
+        <p:spPr>
+          <a:xfrm>
+            <a:off x="7619823" y="1828800"/>
+            <a:ext cx="914400" cy="457200"/>
+          </a:xfrm>
+          <a:prstGeom prst="rect">
+            <a:avLst/>
+          </a:prstGeom>
+          <a:noFill/>
+        </p:spPr>
+        <p:txBody>
+          <a:bodyPr wrap="square">
+            <a:spAutoFit/>
+          </a:bodyPr>
+          <a:lstStyle/>
+          <a:p>
+            <a:pPr algn="l">
+              <a:defRPr sz="3000" b="1" i="0">
+                <a:solidFill>
+                  <a:srgbClr val="252845"/>
+                </a:solidFill>
+                <a:latin typeface="Arial"/>
+              </a:defRPr>
+            </a:pPr>
+            <a:r>
+              <a:t>01</a:t>
+            </a:r>
+          </a:p>
+        </p:txBody>
+      </p:sp>
+      <p:sp>
+        <p:nvSpPr>
+          <p:cNvPr id="12" name="Rectangle 11"/>
+          <p:cNvSpPr/>
+          <p:nvPr/>
+        </p:nvSpPr>
+        <p:spPr>
+          <a:xfrm>
+            <a:off x="8717103" y="1920240"/>
+            <a:ext cx="109728" cy="109728"/>
+          </a:xfrm>
+          <a:prstGeom prst="rect">
+            <a:avLst/>
+          </a:prstGeom>
+          <a:solidFill>
+            <a:srgbClr val="E6007E"/>
+          </a:solidFill>
+          <a:ln>
+            <a:noFill/>
+          </a:ln>
+        </p:spPr>
+        <p:style>
+          <a:lnRef idx="1">
+            <a:schemeClr val="accent1"/>
+          </a:lnRef>
+          <a:fillRef idx="3">
+            <a:schemeClr val="accent1"/>
+          </a:fillRef>
+          <a:effectRef idx="2">
+            <a:schemeClr val="accent1"/>
+          </a:effectRef>
+          <a:fontRef idx="minor">
+            <a:schemeClr val="lt1"/>
+          </a:fontRef>
+        </p:style>
+        <p:txBody>
+          <a:bodyPr rtlCol="0" anchor="ctr"/>
+          <a:lstStyle/>
+          <a:p>
+            <a:pPr algn="ctr"/>
+          </a:p>
+        </p:txBody>
+      </p:sp>
+      <p:sp>
+        <p:nvSpPr>
+          <p:cNvPr id="13" name="TextBox 12"/>
+          <p:cNvSpPr txBox="1"/>
+          <p:nvPr/>
+        </p:nvSpPr>
+        <p:spPr>
+          <a:xfrm>
+            <a:off x="8991423" y="1847088"/>
+            <a:ext cx="2743200" cy="365760"/>
+          </a:xfrm>
+          <a:prstGeom prst="rect">
+            <a:avLst/>
+          </a:prstGeom>
+          <a:noFill/>
+        </p:spPr>
+        <p:txBody>
+          <a:bodyPr wrap="square">
+            <a:spAutoFit/>
+          </a:bodyPr>
+          <a:lstStyle/>
+          <a:p>
+            <a:pPr algn="l">
+              <a:defRPr sz="1400" b="1" i="0">
+                <a:solidFill>
+                  <a:srgbClr val="E0E2EE"/>
+                </a:solidFill>
+                <a:latin typeface="Arial"/>
+              </a:defRPr>
+            </a:pPr>
+            <a:r>
+              <a:t>Problem &amp; Complications</a:t>
+            </a:r>
+          </a:p>
+        </p:txBody>
+      </p:sp>
+      <p:sp>
+        <p:nvSpPr>
+          <p:cNvPr id="14" name="TextBox 13"/>
+          <p:cNvSpPr txBox="1"/>
+          <p:nvPr/>
+        </p:nvSpPr>
+        <p:spPr>
+          <a:xfrm>
+            <a:off x="7619823" y="3383280"/>
+            <a:ext cx="914400" cy="457200"/>
+          </a:xfrm>
+          <a:prstGeom prst="rect">
+            <a:avLst/>
+          </a:prstGeom>
+          <a:noFill/>
+        </p:spPr>
+        <p:txBody>
+          <a:bodyPr wrap="square">
+            <a:spAutoFit/>
+          </a:bodyPr>
+          <a:lstStyle/>
+          <a:p>
+            <a:pPr algn="l">
+              <a:defRPr sz="3000" b="1" i="0">
+                <a:solidFill>
+                  <a:srgbClr val="252845"/>
+                </a:solidFill>
+                <a:latin typeface="Arial"/>
+              </a:defRPr>
+            </a:pPr>
+            <a:r>
+              <a:t>02</a:t>
+            </a:r>
+          </a:p>
+        </p:txBody>
+      </p:sp>
+      <p:sp>
+        <p:nvSpPr>
+          <p:cNvPr id="15" name="Rectangle 14"/>
+          <p:cNvSpPr/>
+          <p:nvPr/>
+        </p:nvSpPr>
+        <p:spPr>
+          <a:xfrm>
+            <a:off x="8717103" y="3474720"/>
+            <a:ext cx="109728" cy="109728"/>
+          </a:xfrm>
+          <a:prstGeom prst="rect">
+            <a:avLst/>
+          </a:prstGeom>
+          <a:solidFill>
+            <a:srgbClr val="888CA8"/>
+          </a:solidFill>
+          <a:ln>
+            <a:noFill/>
+          </a:ln>
+        </p:spPr>
+        <p:style>
+          <a:lnRef idx="1">
+            <a:schemeClr val="accent1"/>
+          </a:lnRef>
+          <a:fillRef idx="3">
+            <a:schemeClr val="accent1"/>
+          </a:fillRef>
+          <a:effectRef idx="2">
+            <a:schemeClr val="accent1"/>
+          </a:effectRef>
+          <a:fontRef idx="minor">
+            <a:schemeClr val="lt1"/>
+          </a:fontRef>
+        </p:style>
+        <p:txBody>
+          <a:bodyPr rtlCol="0" anchor="ctr"/>
+          <a:lstStyle/>
+          <a:p>
+            <a:pPr algn="ctr"/>
+          </a:p>
+        </p:txBody>
+      </p:sp>
+      <p:sp>
+        <p:nvSpPr>
+          <p:cNvPr id="16" name="TextBox 15"/>
+          <p:cNvSpPr txBox="1"/>
+          <p:nvPr/>
+        </p:nvSpPr>
+        <p:spPr>
+          <a:xfrm>
+            <a:off x="8991423" y="3401568"/>
+            <a:ext cx="2743200" cy="365760"/>
+          </a:xfrm>
+          <a:prstGeom prst="rect">
+            <a:avLst/>
+          </a:prstGeom>
+          <a:noFill/>
+        </p:spPr>
+        <p:txBody>
+          <a:bodyPr wrap="square">
+            <a:spAutoFit/>
+          </a:bodyPr>
+          <a:lstStyle/>
+          <a:p>
+            <a:pPr algn="l">
+              <a:defRPr sz="1400" b="1" i="0">
+                <a:solidFill>
+                  <a:srgbClr val="E0E2EE"/>
+                </a:solidFill>
+                <a:latin typeface="Arial"/>
+              </a:defRPr>
+            </a:pPr>
+            <a:r>
+              <a:t>AI Solution &amp; Features</a:t>
+            </a:r>
+          </a:p>
+        </p:txBody>
+      </p:sp>
+      <p:sp>
+        <p:nvSpPr>
+          <p:cNvPr id="17" name="TextBox 16"/>
+          <p:cNvSpPr txBox="1"/>
+          <p:nvPr/>
+        </p:nvSpPr>
+        <p:spPr>
+          <a:xfrm>
+            <a:off x="7619823" y="4937760"/>
+            <a:ext cx="914400" cy="457200"/>
+          </a:xfrm>
+          <a:prstGeom prst="rect">
+            <a:avLst/>
+          </a:prstGeom>
+          <a:noFill/>
+        </p:spPr>
+        <p:txBody>
+          <a:bodyPr wrap="square">
+            <a:spAutoFit/>
+          </a:bodyPr>
+          <a:lstStyle/>
+          <a:p>
+            <a:pPr algn="l">
+              <a:defRPr sz="3000" b="1" i="0">
+                <a:solidFill>
+                  <a:srgbClr val="252845"/>
+                </a:solidFill>
+                <a:latin typeface="Arial"/>
+              </a:defRPr>
+            </a:pPr>
+            <a:r>
+              <a:t>03</a:t>
+            </a:r>
+          </a:p>
+        </p:txBody>
+      </p:sp>
+      <p:sp>
+        <p:nvSpPr>
+          <p:cNvPr id="18" name="Rectangle 17"/>
+          <p:cNvSpPr/>
+          <p:nvPr/>
+        </p:nvSpPr>
+        <p:spPr>
+          <a:xfrm>
+            <a:off x="8717103" y="5029200"/>
+            <a:ext cx="109728" cy="109728"/>
+          </a:xfrm>
+          <a:prstGeom prst="rect">
+            <a:avLst/>
+          </a:prstGeom>
+          <a:solidFill>
+            <a:srgbClr val="60A5FA"/>
+          </a:solidFill>
+          <a:ln>
+            <a:noFill/>
+          </a:ln>
+        </p:spPr>
+        <p:style>
+          <a:lnRef idx="1">
+            <a:schemeClr val="accent1"/>
+          </a:lnRef>
+          <a:fillRef idx="3">
+            <a:schemeClr val="accent1"/>
+          </a:fillRef>
+          <a:effectRef idx="2">
+            <a:schemeClr val="accent1"/>
+          </a:effectRef>
+          <a:fontRef idx="minor">
+            <a:schemeClr val="lt1"/>
+          </a:fontRef>
+        </p:style>
+        <p:txBody>
+          <a:bodyPr rtlCol="0" anchor="ctr"/>
+          <a:lstStyle/>
+          <a:p>
+            <a:pPr algn="ctr"/>
+          </a:p>
+        </p:txBody>
+      </p:sp>
+      <p:sp>
+        <p:nvSpPr>
+          <p:cNvPr id="19" name="TextBox 18"/>
+          <p:cNvSpPr txBox="1"/>
+          <p:nvPr/>
+        </p:nvSpPr>
+        <p:spPr>
+          <a:xfrm>
+            <a:off x="8991423" y="4956048"/>
+            <a:ext cx="2743200" cy="365760"/>
+          </a:xfrm>
+          <a:prstGeom prst="rect">
+            <a:avLst/>
+          </a:prstGeom>
+          <a:noFill/>
+        </p:spPr>
+        <p:txBody>
+          <a:bodyPr wrap="square">
+            <a:spAutoFit/>
+          </a:bodyPr>
+          <a:lstStyle/>
+          <a:p>
+            <a:pPr algn="l">
+              <a:defRPr sz="1400" b="1" i="0">
+                <a:solidFill>
+                  <a:srgbClr val="E0E2EE"/>
+                </a:solidFill>
+                <a:latin typeface="Arial"/>
+              </a:defRPr>
+            </a:pPr>
+            <a:r>
+              <a:t>Impact &amp; Outcomes</a:t>
             </a:r>
           </a:p>
         </p:txBody>
@@ -3515,7 +3957,7 @@
                 <a:solidFill>
                   <a:srgbClr val="FFFFFF"/>
                 </a:solidFill>
-                <a:latin typeface="Inter"/>
+                <a:latin typeface="Arial"/>
               </a:defRPr>
             </a:pPr>
             <a:r>
@@ -3551,11 +3993,11 @@
                 <a:solidFill>
                   <a:srgbClr val="999CB0"/>
                 </a:solidFill>
-                <a:latin typeface="Inter"/>
+                <a:latin typeface="Arial"/>
               </a:defRPr>
             </a:pPr>
             <a:r>
-              <a:t>Financial Services  •  Requirements Engineering  •  Custom AI Solution</a:t>
+              <a:t>Financial Services • Requirements Engineering • Custom AI Solution</a:t>
             </a:r>
           </a:p>
         </p:txBody>
@@ -3587,7 +4029,7 @@
                 <a:solidFill>
                   <a:srgbClr val="888CA8"/>
                 </a:solidFill>
-                <a:latin typeface="Inter"/>
+                <a:latin typeface="Arial"/>
               </a:defRPr>
             </a:pPr>
             <a:r>
@@ -3666,7 +4108,7 @@
                 <a:solidFill>
                   <a:srgbClr val="E6007E"/>
                 </a:solidFill>
-                <a:latin typeface="Inter"/>
+                <a:latin typeface="Arial"/>
               </a:defRPr>
             </a:pPr>
             <a:r>
@@ -3702,7 +4144,7 @@
                 <a:solidFill>
                   <a:srgbClr val="4A5068"/>
                 </a:solidFill>
-                <a:latin typeface="Inter"/>
+                <a:latin typeface="Arial"/>
               </a:defRPr>
             </a:pPr>
             <a:r>
@@ -3781,7 +4223,7 @@
                 <a:solidFill>
                   <a:srgbClr val="1A1F3D"/>
                 </a:solidFill>
-                <a:latin typeface="Inter"/>
+                <a:latin typeface="Arial"/>
               </a:defRPr>
             </a:pPr>
             <a:r>
@@ -3817,7 +4259,7 @@
                 <a:solidFill>
                   <a:srgbClr val="4A5068"/>
                 </a:solidFill>
-                <a:latin typeface="Inter"/>
+                <a:latin typeface="Arial"/>
               </a:defRPr>
             </a:pPr>
             <a:r>
@@ -3834,7 +4276,7 @@
         </p:nvSpPr>
         <p:spPr>
           <a:xfrm>
-            <a:off x="6095847" y="1005840"/>
+            <a:off x="6095846" y="1005840"/>
             <a:ext cx="9144" cy="502920"/>
           </a:xfrm>
           <a:prstGeom prst="rect">
@@ -3877,7 +4319,7 @@
         </p:nvSpPr>
         <p:spPr>
           <a:xfrm>
-            <a:off x="6553047" y="978408"/>
+            <a:off x="6553046" y="978408"/>
             <a:ext cx="1371600" cy="457200"/>
           </a:xfrm>
           <a:prstGeom prst="rect">
@@ -3896,7 +4338,7 @@
                 <a:solidFill>
                   <a:srgbClr val="1A1F3D"/>
                 </a:solidFill>
-                <a:latin typeface="Inter"/>
+                <a:latin typeface="Arial"/>
               </a:defRPr>
             </a:pPr>
             <a:r>
@@ -3913,7 +4355,7 @@
         </p:nvSpPr>
         <p:spPr>
           <a:xfrm>
-            <a:off x="7924647" y="1033272"/>
+            <a:off x="7924646" y="1033272"/>
             <a:ext cx="1371600" cy="457200"/>
           </a:xfrm>
           <a:prstGeom prst="rect">
@@ -3932,7 +4374,7 @@
                 <a:solidFill>
                   <a:srgbClr val="4A5068"/>
                 </a:solidFill>
-                <a:latin typeface="Inter"/>
+                <a:latin typeface="Arial"/>
               </a:defRPr>
             </a:pPr>
             <a:r>
@@ -3949,7 +4391,7 @@
         </p:nvSpPr>
         <p:spPr>
           <a:xfrm>
-            <a:off x="9143771" y="1005840"/>
+            <a:off x="9143769" y="1005840"/>
             <a:ext cx="9144" cy="502920"/>
           </a:xfrm>
           <a:prstGeom prst="rect">
@@ -3992,7 +4434,7 @@
         </p:nvSpPr>
         <p:spPr>
           <a:xfrm>
-            <a:off x="9600971" y="978408"/>
+            <a:off x="9600969" y="978408"/>
             <a:ext cx="1371600" cy="457200"/>
           </a:xfrm>
           <a:prstGeom prst="rect">
@@ -4011,7 +4453,7 @@
                 <a:solidFill>
                   <a:srgbClr val="1A1F3D"/>
                 </a:solidFill>
-                <a:latin typeface="Inter"/>
+                <a:latin typeface="Arial"/>
               </a:defRPr>
             </a:pPr>
             <a:r>
@@ -4028,7 +4470,7 @@
         </p:nvSpPr>
         <p:spPr>
           <a:xfrm>
-            <a:off x="10972571" y="1033272"/>
+            <a:off x="10972569" y="1033272"/>
             <a:ext cx="1371600" cy="457200"/>
           </a:xfrm>
           <a:prstGeom prst="rect">
@@ -4047,7 +4489,7 @@
                 <a:solidFill>
                   <a:srgbClr val="4A5068"/>
                 </a:solidFill>
-                <a:latin typeface="Inter"/>
+                <a:latin typeface="Arial"/>
               </a:defRPr>
             </a:pPr>
             <a:r>
@@ -4143,7 +4585,7 @@
                 <a:solidFill>
                   <a:srgbClr val="FFFFFF"/>
                 </a:solidFill>
-                <a:latin typeface="Inter"/>
+                <a:latin typeface="Arial"/>
               </a:defRPr>
             </a:pPr>
             <a:r>
@@ -4179,7 +4621,7 @@
                 <a:solidFill>
                   <a:srgbClr val="E6007E"/>
                 </a:solidFill>
-                <a:latin typeface="Inter"/>
+                <a:latin typeface="Arial"/>
               </a:defRPr>
             </a:pPr>
             <a:r>
@@ -4266,7 +4708,7 @@
                 <a:solidFill>
                   <a:srgbClr val="1A1F3D"/>
                 </a:solidFill>
-                <a:latin typeface="Inter"/>
+                <a:latin typeface="Arial"/>
               </a:rPr>
               <a:t>•  Requirements are the #1 bottleneck </a:t>
             </a:r>
@@ -4275,7 +4717,7 @@
                 <a:solidFill>
                   <a:srgbClr val="4A5068"/>
                 </a:solidFill>
-                <a:latin typeface="Inter"/>
+                <a:latin typeface="Arial"/>
               </a:rPr>
               <a:t>in SDLC — 30% of projects delayed by spec gaps</a:t>
             </a:r>
@@ -4294,7 +4736,7 @@
                 <a:solidFill>
                   <a:srgbClr val="1A1F3D"/>
                 </a:solidFill>
-                <a:latin typeface="Inter"/>
+                <a:latin typeface="Arial"/>
               </a:rPr>
               <a:t>•  64% of failed projects </a:t>
             </a:r>
@@ -4303,7 +4745,7 @@
                 <a:solidFill>
                   <a:srgbClr val="4A5068"/>
                 </a:solidFill>
-                <a:latin typeface="Inter"/>
+                <a:latin typeface="Arial"/>
               </a:rPr>
               <a:t>trace root cause to errors in requirements gathering</a:t>
             </a:r>
@@ -4322,7 +4764,7 @@
                 <a:solidFill>
                   <a:srgbClr val="1A1F3D"/>
                 </a:solidFill>
-                <a:latin typeface="Inter"/>
+                <a:latin typeface="Arial"/>
               </a:rPr>
               <a:t>•  Rework costs 15x more </a:t>
             </a:r>
@@ -4331,7 +4773,7 @@
                 <a:solidFill>
                   <a:srgbClr val="4A5068"/>
                 </a:solidFill>
-                <a:latin typeface="Inter"/>
+                <a:latin typeface="Arial"/>
               </a:rPr>
               <a:t>when defects from requirements surface in production</a:t>
             </a:r>
@@ -4350,7 +4792,7 @@
                 <a:solidFill>
                   <a:srgbClr val="1A1F3D"/>
                 </a:solidFill>
-                <a:latin typeface="Inter"/>
+                <a:latin typeface="Arial"/>
               </a:rPr>
               <a:t>•  BAs spend most time on low-value tasks </a:t>
             </a:r>
@@ -4359,7 +4801,7 @@
                 <a:solidFill>
                   <a:srgbClr val="4A5068"/>
                 </a:solidFill>
-                <a:latin typeface="Inter"/>
+                <a:latin typeface="Arial"/>
               </a:rPr>
               <a:t>— formatting &amp; consistency checks</a:t>
             </a:r>
@@ -4378,7 +4820,7 @@
                 <a:solidFill>
                   <a:srgbClr val="1A1F3D"/>
                 </a:solidFill>
-                <a:latin typeface="Inter"/>
+                <a:latin typeface="Arial"/>
               </a:rPr>
               <a:t>•  No scalable alternative </a:t>
             </a:r>
@@ -4387,7 +4829,7 @@
                 <a:solidFill>
                   <a:srgbClr val="4A5068"/>
                 </a:solidFill>
-                <a:latin typeface="Inter"/>
+                <a:latin typeface="Arial"/>
               </a:rPr>
               <a:t>— tools lack financial services domain context</a:t>
             </a:r>
@@ -4481,7 +4923,7 @@
                 <a:solidFill>
                   <a:srgbClr val="FFFFFF"/>
                 </a:solidFill>
-                <a:latin typeface="Inter"/>
+                <a:latin typeface="Arial"/>
               </a:defRPr>
             </a:pPr>
             <a:r>
@@ -4517,7 +4959,7 @@
                 <a:solidFill>
                   <a:srgbClr val="1A1F3D"/>
                 </a:solidFill>
-                <a:latin typeface="Inter"/>
+                <a:latin typeface="Arial"/>
               </a:defRPr>
             </a:pPr>
             <a:r>
@@ -4604,7 +5046,7 @@
                 <a:solidFill>
                   <a:srgbClr val="1A1F3D"/>
                 </a:solidFill>
-                <a:latin typeface="Inter"/>
+                <a:latin typeface="Arial"/>
               </a:rPr>
               <a:t>•  Automates generation </a:t>
             </a:r>
@@ -4613,7 +5055,7 @@
                 <a:solidFill>
                   <a:srgbClr val="4A5068"/>
                 </a:solidFill>
-                <a:latin typeface="Inter"/>
+                <a:latin typeface="Arial"/>
               </a:rPr>
               <a:t>of epics, stories, and test cases from high-level inputs</a:t>
             </a:r>
@@ -4632,7 +5074,7 @@
                 <a:solidFill>
                   <a:srgbClr val="1A1F3D"/>
                 </a:solidFill>
-                <a:latin typeface="Inter"/>
+                <a:latin typeface="Arial"/>
               </a:rPr>
               <a:t>•  Custom-built AI </a:t>
             </a:r>
@@ -4641,7 +5083,7 @@
                 <a:solidFill>
                   <a:srgbClr val="4A5068"/>
                 </a:solidFill>
-                <a:latin typeface="Inter"/>
+                <a:latin typeface="Arial"/>
               </a:rPr>
               <a:t>trained on 6 corpuses of regulatory &amp; standards docs</a:t>
             </a:r>
@@ -4660,7 +5102,7 @@
                 <a:solidFill>
                   <a:srgbClr val="1A1F3D"/>
                 </a:solidFill>
-                <a:latin typeface="Inter"/>
+                <a:latin typeface="Arial"/>
               </a:rPr>
               <a:t>•  Outputs conform to internal standards </a:t>
             </a:r>
@@ -4669,7 +5111,7 @@
                 <a:solidFill>
                   <a:srgbClr val="4A5068"/>
                 </a:solidFill>
-                <a:latin typeface="Inter"/>
+                <a:latin typeface="Arial"/>
               </a:rPr>
               <a:t>— templates, taxonomy, criteria</a:t>
             </a:r>
@@ -4688,7 +5130,7 @@
                 <a:solidFill>
                   <a:srgbClr val="1A1F3D"/>
                 </a:solidFill>
-                <a:latin typeface="Inter"/>
+                <a:latin typeface="Arial"/>
               </a:rPr>
               <a:t>•  Model &amp; tech agnostic </a:t>
             </a:r>
@@ -4697,7 +5139,7 @@
                 <a:solidFill>
                   <a:srgbClr val="4A5068"/>
                 </a:solidFill>
-                <a:latin typeface="Inter"/>
+                <a:latin typeface="Arial"/>
               </a:rPr>
               <a:t>— swap underlying LLMs as capabilities evolve</a:t>
             </a:r>
@@ -4716,7 +5158,7 @@
                 <a:solidFill>
                   <a:srgbClr val="1A1F3D"/>
                 </a:solidFill>
-                <a:latin typeface="Inter"/>
+                <a:latin typeface="Arial"/>
               </a:rPr>
               <a:t>•  Zero-disruption deployment </a:t>
             </a:r>
@@ -4725,7 +5167,7 @@
                 <a:solidFill>
                   <a:srgbClr val="4A5068"/>
                 </a:solidFill>
-                <a:latin typeface="Inter"/>
+                <a:latin typeface="Arial"/>
               </a:rPr>
               <a:t>— parallel to existing pipelines; 2 wk pilot</a:t>
             </a:r>
@@ -4819,7 +5261,7 @@
                 <a:solidFill>
                   <a:srgbClr val="FFFFFF"/>
                 </a:solidFill>
-                <a:latin typeface="Inter"/>
+                <a:latin typeface="Arial"/>
               </a:defRPr>
             </a:pPr>
             <a:r>
@@ -4855,7 +5297,7 @@
                 <a:solidFill>
                   <a:srgbClr val="2563EB"/>
                 </a:solidFill>
-                <a:latin typeface="Inter"/>
+                <a:latin typeface="Arial"/>
               </a:defRPr>
             </a:pPr>
             <a:r>
@@ -4942,7 +5384,7 @@
                 <a:solidFill>
                   <a:srgbClr val="1A1F3D"/>
                 </a:solidFill>
-                <a:latin typeface="Inter"/>
+                <a:latin typeface="Arial"/>
               </a:rPr>
               <a:t>•  Up to 45% reduction </a:t>
             </a:r>
@@ -4951,7 +5393,7 @@
                 <a:solidFill>
                   <a:srgbClr val="4A5068"/>
                 </a:solidFill>
-                <a:latin typeface="Inter"/>
+                <a:latin typeface="Arial"/>
               </a:rPr>
               <a:t>in manual effort for requirements authoring</a:t>
             </a:r>
@@ -4970,7 +5412,7 @@
                 <a:solidFill>
                   <a:srgbClr val="1A1F3D"/>
                 </a:solidFill>
-                <a:latin typeface="Inter"/>
+                <a:latin typeface="Arial"/>
               </a:rPr>
               <a:t>•  1.5x throughput </a:t>
             </a:r>
@@ -4979,7 +5421,7 @@
                 <a:solidFill>
                   <a:srgbClr val="4A5068"/>
                 </a:solidFill>
-                <a:latin typeface="Inter"/>
+                <a:latin typeface="Arial"/>
               </a:rPr>
               <a:t>— higher-quality requirements in less time</a:t>
             </a:r>
@@ -4998,7 +5440,7 @@
                 <a:solidFill>
                   <a:srgbClr val="1A1F3D"/>
                 </a:solidFill>
-                <a:latin typeface="Inter"/>
+                <a:latin typeface="Arial"/>
               </a:rPr>
               <a:t>•  Accuracy &amp; consistency </a:t>
             </a:r>
@@ -5007,7 +5449,7 @@
                 <a:solidFill>
                   <a:srgbClr val="4A5068"/>
                 </a:solidFill>
-                <a:latin typeface="Inter"/>
+                <a:latin typeface="Arial"/>
               </a:rPr>
               <a:t>improved from first draft, fewer review cycles</a:t>
             </a:r>
@@ -5026,7 +5468,7 @@
                 <a:solidFill>
                   <a:srgbClr val="1A1F3D"/>
                 </a:solidFill>
-                <a:latin typeface="Inter"/>
+                <a:latin typeface="Arial"/>
               </a:rPr>
               <a:t>•  BAs shift to high-value work </a:t>
             </a:r>
@@ -5035,7 +5477,7 @@
                 <a:solidFill>
                   <a:srgbClr val="4A5068"/>
                 </a:solidFill>
-                <a:latin typeface="Inter"/>
+                <a:latin typeface="Arial"/>
               </a:rPr>
               <a:t>— stakeholder engagement &amp; strategy</a:t>
             </a:r>
@@ -5054,7 +5496,7 @@
                 <a:solidFill>
                   <a:srgbClr val="1A1F3D"/>
                 </a:solidFill>
-                <a:latin typeface="Inter"/>
+                <a:latin typeface="Arial"/>
               </a:rPr>
               <a:t>•  Sustainable &amp; scalable </a:t>
             </a:r>
@@ -5063,7 +5505,7 @@
                 <a:solidFill>
                   <a:srgbClr val="4A5068"/>
                 </a:solidFill>
-                <a:latin typeface="Inter"/>
+                <a:latin typeface="Arial"/>
               </a:rPr>
               <a:t>— pilot-to-production proven in 7 weeks</a:t>
             </a:r>
@@ -5226,7 +5668,7 @@
                 <a:solidFill>
                   <a:srgbClr val="7B8198"/>
                 </a:solidFill>
-                <a:latin typeface="Inter"/>
+                <a:latin typeface="Arial"/>
               </a:defRPr>
             </a:pPr>
             <a:r>
@@ -5262,11 +5704,11 @@
                 <a:solidFill>
                   <a:srgbClr val="7B8198"/>
                 </a:solidFill>
-                <a:latin typeface="Inter"/>
+                <a:latin typeface="Arial"/>
               </a:defRPr>
             </a:pPr>
             <a:r>
-              <a:t>BA Genie  •  SDLC / Engineering  •  Financial Services</a:t>
+              <a:t>BA Genie • SDLC / Engineering</a:t>
             </a:r>
           </a:p>
         </p:txBody>
@@ -5410,7 +5852,7 @@
                 <a:solidFill>
                   <a:srgbClr val="FFFFFF"/>
                 </a:solidFill>
-                <a:latin typeface="Inter"/>
+                <a:latin typeface="Arial"/>
               </a:defRPr>
             </a:pPr>
             <a:r>
@@ -5446,11 +5888,11 @@
                 <a:solidFill>
                   <a:srgbClr val="999CB0"/>
                 </a:solidFill>
-                <a:latin typeface="Inter"/>
+                <a:latin typeface="Arial"/>
               </a:defRPr>
             </a:pPr>
             <a:r>
-              <a:t>[Industry]  •  [Function / Process Area]  •  [Solution Type]</a:t>
+              <a:t>[Industry] • [Function / Process Area] • [Solution Type]</a:t>
             </a:r>
           </a:p>
         </p:txBody>
@@ -5482,7 +5924,7 @@
                 <a:solidFill>
                   <a:srgbClr val="888CA8"/>
                 </a:solidFill>
-                <a:latin typeface="Inter"/>
+                <a:latin typeface="Arial"/>
               </a:defRPr>
             </a:pPr>
             <a:r>
@@ -5561,7 +6003,7 @@
                 <a:solidFill>
                   <a:srgbClr val="D4DAE5"/>
                 </a:solidFill>
-                <a:latin typeface="Inter"/>
+                <a:latin typeface="Arial"/>
               </a:defRPr>
             </a:pPr>
             <a:r>
@@ -5597,7 +6039,7 @@
                 <a:solidFill>
                   <a:srgbClr val="7B8198"/>
                 </a:solidFill>
-                <a:latin typeface="Inter"/>
+                <a:latin typeface="Arial"/>
               </a:defRPr>
             </a:pPr>
             <a:r>
@@ -5676,7 +6118,7 @@
                 <a:solidFill>
                   <a:srgbClr val="D4DAE5"/>
                 </a:solidFill>
-                <a:latin typeface="Inter"/>
+                <a:latin typeface="Arial"/>
               </a:defRPr>
             </a:pPr>
             <a:r>
@@ -5712,7 +6154,7 @@
                 <a:solidFill>
                   <a:srgbClr val="7B8198"/>
                 </a:solidFill>
-                <a:latin typeface="Inter"/>
+                <a:latin typeface="Arial"/>
               </a:defRPr>
             </a:pPr>
             <a:r>
@@ -5729,7 +6171,7 @@
         </p:nvSpPr>
         <p:spPr>
           <a:xfrm>
-            <a:off x="6095847" y="1005840"/>
+            <a:off x="6095846" y="1005840"/>
             <a:ext cx="9144" cy="502920"/>
           </a:xfrm>
           <a:prstGeom prst="rect">
@@ -5772,7 +6214,7 @@
         </p:nvSpPr>
         <p:spPr>
           <a:xfrm>
-            <a:off x="6553047" y="978408"/>
+            <a:off x="6553046" y="978408"/>
             <a:ext cx="1371600" cy="457200"/>
           </a:xfrm>
           <a:prstGeom prst="rect">
@@ -5791,7 +6233,7 @@
                 <a:solidFill>
                   <a:srgbClr val="D4DAE5"/>
                 </a:solidFill>
-                <a:latin typeface="Inter"/>
+                <a:latin typeface="Arial"/>
               </a:defRPr>
             </a:pPr>
             <a:r>
@@ -5808,7 +6250,7 @@
         </p:nvSpPr>
         <p:spPr>
           <a:xfrm>
-            <a:off x="7924647" y="1033272"/>
+            <a:off x="7924646" y="1033272"/>
             <a:ext cx="1371600" cy="457200"/>
           </a:xfrm>
           <a:prstGeom prst="rect">
@@ -5827,7 +6269,7 @@
                 <a:solidFill>
                   <a:srgbClr val="7B8198"/>
                 </a:solidFill>
-                <a:latin typeface="Inter"/>
+                <a:latin typeface="Arial"/>
               </a:defRPr>
             </a:pPr>
             <a:r>
@@ -5844,7 +6286,7 @@
         </p:nvSpPr>
         <p:spPr>
           <a:xfrm>
-            <a:off x="9143771" y="1005840"/>
+            <a:off x="9143769" y="1005840"/>
             <a:ext cx="9144" cy="502920"/>
           </a:xfrm>
           <a:prstGeom prst="rect">
@@ -5887,7 +6329,7 @@
         </p:nvSpPr>
         <p:spPr>
           <a:xfrm>
-            <a:off x="9600971" y="978408"/>
+            <a:off x="9600969" y="978408"/>
             <a:ext cx="1371600" cy="457200"/>
           </a:xfrm>
           <a:prstGeom prst="rect">
@@ -5906,7 +6348,7 @@
                 <a:solidFill>
                   <a:srgbClr val="D4DAE5"/>
                 </a:solidFill>
-                <a:latin typeface="Inter"/>
+                <a:latin typeface="Arial"/>
               </a:defRPr>
             </a:pPr>
             <a:r>
@@ -5923,7 +6365,7 @@
         </p:nvSpPr>
         <p:spPr>
           <a:xfrm>
-            <a:off x="10972571" y="1033272"/>
+            <a:off x="10972569" y="1033272"/>
             <a:ext cx="1371600" cy="457200"/>
           </a:xfrm>
           <a:prstGeom prst="rect">
@@ -5942,7 +6384,7 @@
                 <a:solidFill>
                   <a:srgbClr val="7B8198"/>
                 </a:solidFill>
-                <a:latin typeface="Inter"/>
+                <a:latin typeface="Arial"/>
               </a:defRPr>
             </a:pPr>
             <a:r>
@@ -6038,7 +6480,7 @@
                 <a:solidFill>
                   <a:srgbClr val="FFFFFF"/>
                 </a:solidFill>
-                <a:latin typeface="Inter"/>
+                <a:latin typeface="Arial"/>
               </a:defRPr>
             </a:pPr>
             <a:r>
@@ -6074,7 +6516,7 @@
                 <a:solidFill>
                   <a:srgbClr val="E6007E"/>
                 </a:solidFill>
-                <a:latin typeface="Inter"/>
+                <a:latin typeface="Arial"/>
               </a:defRPr>
             </a:pPr>
             <a:r>
@@ -6161,9 +6603,9 @@
                 <a:solidFill>
                   <a:srgbClr val="7B8198"/>
                 </a:solidFill>
-                <a:latin typeface="Inter"/>
+                <a:latin typeface="Arial"/>
               </a:rPr>
-              <a:t>•  What is the business context? What process or function is affected?</a:t>
+              <a:t>•  What is the business context?</a:t>
             </a:r>
           </a:p>
           <a:p>
@@ -6180,9 +6622,9 @@
                 <a:solidFill>
                   <a:srgbClr val="7B8198"/>
                 </a:solidFill>
-                <a:latin typeface="Inter"/>
+                <a:latin typeface="Arial"/>
               </a:rPr>
-              <a:t>•  What is the core problem? What breaks, fails, or underperforms?</a:t>
+              <a:t>•  What is the core problem?</a:t>
             </a:r>
           </a:p>
           <a:p>
@@ -6199,9 +6641,9 @@
                 <a:solidFill>
                   <a:srgbClr val="7B8198"/>
                 </a:solidFill>
-                <a:latin typeface="Inter"/>
+                <a:latin typeface="Arial"/>
               </a:rPr>
-              <a:t>•  What makes it worse? Volume, complexity, regulatory pressure?</a:t>
+              <a:t>•  What makes it worse?</a:t>
             </a:r>
           </a:p>
           <a:p>
@@ -6218,9 +6660,9 @@
                 <a:solidFill>
                   <a:srgbClr val="7B8198"/>
                 </a:solidFill>
-                <a:latin typeface="Inter"/>
+                <a:latin typeface="Arial"/>
               </a:rPr>
-              <a:t>•  Why isn't it solved already? What have teams tried that fell short?</a:t>
+              <a:t>•  Why isn't it solved?</a:t>
             </a:r>
           </a:p>
           <a:p>
@@ -6237,9 +6679,9 @@
                 <a:solidFill>
                   <a:srgbClr val="7B8198"/>
                 </a:solidFill>
-                <a:latin typeface="Inter"/>
+                <a:latin typeface="Arial"/>
               </a:rPr>
-              <a:t>•  Cost of inaction? Risk, lost revenue, attrition, compliance exposure?</a:t>
+              <a:t>•  Cost of inaction?</a:t>
             </a:r>
           </a:p>
         </p:txBody>
@@ -6331,7 +6773,7 @@
                 <a:solidFill>
                   <a:srgbClr val="FFFFFF"/>
                 </a:solidFill>
-                <a:latin typeface="Inter"/>
+                <a:latin typeface="Arial"/>
               </a:defRPr>
             </a:pPr>
             <a:r>
@@ -6367,7 +6809,7 @@
                 <a:solidFill>
                   <a:srgbClr val="1A1F3D"/>
                 </a:solidFill>
-                <a:latin typeface="Inter"/>
+                <a:latin typeface="Arial"/>
               </a:defRPr>
             </a:pPr>
             <a:r>
@@ -6454,9 +6896,9 @@
                 <a:solidFill>
                   <a:srgbClr val="7B8198"/>
                 </a:solidFill>
-                <a:latin typeface="Inter"/>
+                <a:latin typeface="Arial"/>
               </a:rPr>
-              <a:t>•  What does the solution do in one sentence?</a:t>
+              <a:t>•  What does the solution do?</a:t>
             </a:r>
           </a:p>
           <a:p>
@@ -6473,9 +6915,9 @@
                 <a:solidFill>
                   <a:srgbClr val="7B8198"/>
                 </a:solidFill>
-                <a:latin typeface="Inter"/>
+                <a:latin typeface="Arial"/>
               </a:rPr>
-              <a:t>•  What are 2-3 key features? What can the user do with it?</a:t>
+              <a:t>•  Key features?</a:t>
             </a:r>
           </a:p>
           <a:p>
@@ -6492,9 +6934,9 @@
                 <a:solidFill>
                   <a:srgbClr val="7B8198"/>
                 </a:solidFill>
-                <a:latin typeface="Inter"/>
+                <a:latin typeface="Arial"/>
               </a:rPr>
-              <a:t>•  What makes it differentiated? Custom model, proprietary data, UX?</a:t>
+              <a:t>•  What's differentiated?</a:t>
             </a:r>
           </a:p>
           <a:p>
@@ -6511,9 +6953,9 @@
                 <a:solidFill>
                   <a:srgbClr val="7B8198"/>
                 </a:solidFill>
-                <a:latin typeface="Inter"/>
+                <a:latin typeface="Arial"/>
               </a:rPr>
-              <a:t>•  How does it integrate? API, plug-in, standalone, embedded?</a:t>
+              <a:t>•  How does it integrate?</a:t>
             </a:r>
           </a:p>
           <a:p>
@@ -6530,9 +6972,9 @@
                 <a:solidFill>
                   <a:srgbClr val="7B8198"/>
                 </a:solidFill>
-                <a:latin typeface="Inter"/>
+                <a:latin typeface="Arial"/>
               </a:rPr>
-              <a:t>•  How fast to deploy? What is the pilot timeline and effort?</a:t>
+              <a:t>•  How fast to deploy?</a:t>
             </a:r>
           </a:p>
         </p:txBody>
@@ -6624,7 +7066,7 @@
                 <a:solidFill>
                   <a:srgbClr val="FFFFFF"/>
                 </a:solidFill>
-                <a:latin typeface="Inter"/>
+                <a:latin typeface="Arial"/>
               </a:defRPr>
             </a:pPr>
             <a:r>
@@ -6660,7 +7102,7 @@
                 <a:solidFill>
                   <a:srgbClr val="2563EB"/>
                 </a:solidFill>
-                <a:latin typeface="Inter"/>
+                <a:latin typeface="Arial"/>
               </a:defRPr>
             </a:pPr>
             <a:r>
@@ -6747,9 +7189,9 @@
                 <a:solidFill>
                   <a:srgbClr val="7B8198"/>
                 </a:solidFill>
-                <a:latin typeface="Inter"/>
+                <a:latin typeface="Arial"/>
               </a:rPr>
-              <a:t>•  Headline metric? (e.g., X% reduction in time, cost, or errors)</a:t>
+              <a:t>•  Headline metric?</a:t>
             </a:r>
           </a:p>
           <a:p>
@@ -6766,9 +7208,9 @@
                 <a:solidFill>
                   <a:srgbClr val="7B8198"/>
                 </a:solidFill>
-                <a:latin typeface="Inter"/>
+                <a:latin typeface="Arial"/>
               </a:rPr>
-              <a:t>•  Secondary metric? (e.g., throughput, capacity, accuracy lift)</a:t>
+              <a:t>•  Secondary metric?</a:t>
             </a:r>
           </a:p>
           <a:p>
@@ -6785,9 +7227,9 @@
                 <a:solidFill>
                   <a:srgbClr val="7B8198"/>
                 </a:solidFill>
-                <a:latin typeface="Inter"/>
+                <a:latin typeface="Arial"/>
               </a:rPr>
-              <a:t>•  Qualitative improvements? Speed, confidence, satisfaction?</a:t>
+              <a:t>•  Qualitative improvements?</a:t>
             </a:r>
           </a:p>
           <a:p>
@@ -6804,9 +7246,9 @@
                 <a:solidFill>
                   <a:srgbClr val="7B8198"/>
                 </a:solidFill>
-                <a:latin typeface="Inter"/>
+                <a:latin typeface="Arial"/>
               </a:rPr>
-              <a:t>•  How does the team's work change? What do they stop/start?</a:t>
+              <a:t>•  How does work change?</a:t>
             </a:r>
           </a:p>
           <a:p>
@@ -6823,9 +7265,9 @@
                 <a:solidFill>
                   <a:srgbClr val="7B8198"/>
                 </a:solidFill>
-                <a:latin typeface="Inter"/>
+                <a:latin typeface="Arial"/>
               </a:rPr>
-              <a:t>•  Is it scalable? Can it expand to other teams or regions?</a:t>
+              <a:t>•  Is it scalable?</a:t>
             </a:r>
           </a:p>
         </p:txBody>
@@ -6986,7 +7428,7 @@
                 <a:solidFill>
                   <a:srgbClr val="7B8198"/>
                 </a:solidFill>
-                <a:latin typeface="Inter"/>
+                <a:latin typeface="Arial"/>
               </a:defRPr>
             </a:pPr>
             <a:r>
@@ -7022,11 +7464,11 @@
                 <a:solidFill>
                   <a:srgbClr val="7B8198"/>
                 </a:solidFill>
-                <a:latin typeface="Inter"/>
+                <a:latin typeface="Arial"/>
               </a:defRPr>
             </a:pPr>
             <a:r>
-              <a:t>[Solution Name]  •  [Domain]</a:t>
+              <a:t>[Solution Name] • [Domain]</a:t>
             </a:r>
           </a:p>
         </p:txBody>

</xml_diff>